<commit_message>
slides: add slide 6 'Metric definitions & chance levels' (9 LaTeX formulas: disc_resid, pear_resid, S_Agap, probe_A, probe_Dperm, crossTF_div, collectri/fate/graph AUROC) + KEY distinction (probe_A used vs S_Agap useful; grn disc=retrieval-top1 vs disc_resid); renumber to 15 slides
</commit_message>
<xml_diff>
--- a/slides/exp20_load_bearing.pptx
+++ b/slides/exp20_load_bearing.pptx
@@ -19,6 +19,7 @@
     <p:sldId id="267" r:id="rId18"/>
     <p:sldId id="268" r:id="rId19"/>
     <p:sldId id="269" r:id="rId20"/>
+    <p:sldId id="270" r:id="rId21"/>
   </p:sldIdLst>
   <p:sldSz cx="12191695" cy="6858000" type="screen4x3"/>
   <p:notesSz cx="6858000" cy="9144000"/>
@@ -3362,14 +3363,14 @@
               </a:defRPr>
             </a:pPr>
             <a:r>
-              <a:t>10 · Objective sweep — break mode collapse, but not generalization</a:t>
+              <a:t>10 · Biology — the projected GRN is prior memorization</a:t>
             </a:r>
           </a:p>
         </p:txBody>
       </p:sp>
       <p:pic>
         <p:nvPicPr>
-          <p:cNvPr id="4" name="Picture 3" descr="decomp.png"/>
+          <p:cNvPr id="4" name="Picture 3" descr="fig4_biology_grn.png"/>
           <p:cNvPicPr>
             <a:picLocks noChangeAspect="1"/>
           </p:cNvPicPr>
@@ -3383,8 +3384,8 @@
         </p:blipFill>
         <p:spPr>
           <a:xfrm>
-            <a:off x="457200" y="914400"/>
-            <a:ext cx="7863840" cy="1410041"/>
+            <a:off x="457200" y="960120"/>
+            <a:ext cx="9231464" cy="4937760"/>
           </a:xfrm>
           <a:prstGeom prst="rect">
             <a:avLst/>
@@ -3399,68 +3400,8 @@
         </p:nvSpPr>
         <p:spPr>
           <a:xfrm>
-            <a:off x="502920" y="1600200"/>
-            <a:ext cx="8686800" cy="365760"/>
-          </a:xfrm>
-          <a:prstGeom prst="rect">
-            <a:avLst/>
-          </a:prstGeom>
-          <a:noFill/>
-        </p:spPr>
-        <p:txBody>
-          <a:bodyPr wrap="square">
-            <a:spAutoFit/>
-          </a:bodyPr>
-          <a:lstStyle/>
-          <a:p>
-            <a:pPr algn="l">
-              <a:defRPr sz="1300" b="0" i="0">
-                <a:solidFill>
-                  <a:srgbClr val="666666"/>
-                </a:solidFill>
-                <a:latin typeface="Calibri"/>
-              </a:defRPr>
-            </a:pPr>
-            <a:r>
-              <a:t>Lever A: pseudobulk per-TF target (SNR).   Lever B: project the shared direction out of the loss.</a:t>
-            </a:r>
-          </a:p>
-        </p:txBody>
-      </p:sp>
-      <p:pic>
-        <p:nvPicPr>
-          <p:cNvPr id="6" name="Picture 5" descr="fig5_Rsweep.png"/>
-          <p:cNvPicPr>
-            <a:picLocks noChangeAspect="1"/>
-          </p:cNvPicPr>
-          <p:nvPr/>
-        </p:nvPicPr>
-        <p:blipFill>
-          <a:blip r:embed="rId3"/>
-          <a:stretch>
-            <a:fillRect/>
-          </a:stretch>
-        </p:blipFill>
-        <p:spPr>
-          <a:xfrm>
-            <a:off x="457200" y="2011680"/>
-            <a:ext cx="11247120" cy="4498848"/>
-          </a:xfrm>
-          <a:prstGeom prst="rect">
-            <a:avLst/>
-          </a:prstGeom>
-        </p:spPr>
-      </p:pic>
-      <p:sp>
-        <p:nvSpPr>
-          <p:cNvPr id="7" name="TextBox 6"/>
-          <p:cNvSpPr txBox="1"/>
-          <p:nvPr/>
-        </p:nvSpPr>
-        <p:spPr>
-          <a:xfrm>
-            <a:off x="548640" y="6263640"/>
-            <a:ext cx="11338560" cy="731520"/>
+            <a:off x="8229600" y="1371600"/>
+            <a:ext cx="3749039" cy="4572000"/>
           </a:xfrm>
           <a:prstGeom prst="rect">
             <a:avLst/>
@@ -3477,7 +3418,7 @@
               <a:spcAft>
                 <a:spcPts val="600"/>
               </a:spcAft>
-              <a:defRPr sz="1250">
+              <a:defRPr sz="1350">
                 <a:solidFill>
                   <a:srgbClr val="1A1A2E"/>
                 </a:solidFill>
@@ -3485,7 +3426,91 @@
               </a:defRPr>
             </a:pPr>
             <a:r>
-              <a:t>• Pseudobulk (Lever A) lifts crossTF_div 0.03→0.2 and probe_A→0.9 (A engaged) — but disc stays at chance: diverse-but-WRONG. Project-out alone (R3) does nothing. The binding constraint is zero-shot generalization.</a:t>
+              <a:t>• CollecTRI AUROC 0.98 (prior ON) → 0.57 (prior OFF) = co-expression floor.</a:t>
+            </a:r>
+          </a:p>
+          <a:p>
+            <a:pPr>
+              <a:spcAft>
+                <a:spcPts val="600"/>
+              </a:spcAft>
+              <a:defRPr sz="1350">
+                <a:solidFill>
+                  <a:srgbClr val="1A1A2E"/>
+                </a:solidFill>
+                <a:latin typeface="Calibri"/>
+              </a:defRPr>
+            </a:pPr>
+            <a:r>
+              <a:t>• Shuffling A does NOT drop it → the signal lives in the decoder (D·Dᵀ), not A.</a:t>
+            </a:r>
+          </a:p>
+          <a:p>
+            <a:pPr>
+              <a:spcAft>
+                <a:spcPts val="600"/>
+              </a:spcAft>
+              <a:defRPr sz="1350">
+                <a:solidFill>
+                  <a:srgbClr val="1A1A2E"/>
+                </a:solidFill>
+                <a:latin typeface="Calibri"/>
+              </a:defRPr>
+            </a:pPr>
+            <a:r>
+              <a:t>• Fetal-atlas FATE hierarchy: AUROC 0.51 = chance → no developmental structure.</a:t>
+            </a:r>
+          </a:p>
+          <a:p>
+            <a:pPr>
+              <a:spcAft>
+                <a:spcPts val="600"/>
+              </a:spcAft>
+              <a:defRPr sz="1350">
+                <a:solidFill>
+                  <a:srgbClr val="1A1A2E"/>
+                </a:solidFill>
+                <a:latin typeface="Calibri"/>
+              </a:defRPr>
+            </a:pPr>
+            <a:r>
+              <a:t>• random-D → chance confirms D carries the (co-expression) signal.</a:t>
+            </a:r>
+          </a:p>
+        </p:txBody>
+      </p:sp>
+      <p:sp>
+        <p:nvSpPr>
+          <p:cNvPr id="6" name="TextBox 5"/>
+          <p:cNvSpPr txBox="1"/>
+          <p:nvPr/>
+        </p:nvSpPr>
+        <p:spPr>
+          <a:xfrm>
+            <a:off x="365760" y="6455664"/>
+            <a:ext cx="11430000" cy="320040"/>
+          </a:xfrm>
+          <a:prstGeom prst="rect">
+            <a:avLst/>
+          </a:prstGeom>
+          <a:noFill/>
+        </p:spPr>
+        <p:txBody>
+          <a:bodyPr wrap="square">
+            <a:spAutoFit/>
+          </a:bodyPr>
+          <a:lstStyle/>
+          <a:p>
+            <a:pPr algn="l">
+              <a:defRPr sz="1000" b="0" i="1">
+                <a:solidFill>
+                  <a:srgbClr val="666666"/>
+                </a:solidFill>
+                <a:latin typeface="Calibri"/>
+              </a:defRPr>
+            </a:pPr>
+            <a:r>
+              <a:t>Prior-free GRN validation: neither TF→target edges nor developmental hierarchy are recovered from data.</a:t>
             </a:r>
           </a:p>
         </p:txBody>
@@ -3591,14 +3616,14 @@
               </a:defRPr>
             </a:pPr>
             <a:r>
-              <a:t>11 · Generalization is the wall — memorize seen, fail unseen</a:t>
+              <a:t>11 · Objective sweep — break mode collapse, but not generalization</a:t>
             </a:r>
           </a:p>
         </p:txBody>
       </p:sp>
       <p:pic>
         <p:nvPicPr>
-          <p:cNvPr id="4" name="Picture 3" descr="fig6_train_vs_heldout.png"/>
+          <p:cNvPr id="4" name="Picture 3" descr="decomp.png"/>
           <p:cNvPicPr>
             <a:picLocks noChangeAspect="1"/>
           </p:cNvPicPr>
@@ -3612,8 +3637,8 @@
         </p:blipFill>
         <p:spPr>
           <a:xfrm>
-            <a:off x="457200" y="1051560"/>
-            <a:ext cx="8940800" cy="5029200"/>
+            <a:off x="457200" y="914400"/>
+            <a:ext cx="7863840" cy="1410041"/>
           </a:xfrm>
           <a:prstGeom prst="rect">
             <a:avLst/>
@@ -3628,8 +3653,68 @@
         </p:nvSpPr>
         <p:spPr>
           <a:xfrm>
-            <a:off x="7680960" y="1463040"/>
-            <a:ext cx="4206240" cy="4572000"/>
+            <a:off x="502920" y="1600200"/>
+            <a:ext cx="8686800" cy="365760"/>
+          </a:xfrm>
+          <a:prstGeom prst="rect">
+            <a:avLst/>
+          </a:prstGeom>
+          <a:noFill/>
+        </p:spPr>
+        <p:txBody>
+          <a:bodyPr wrap="square">
+            <a:spAutoFit/>
+          </a:bodyPr>
+          <a:lstStyle/>
+          <a:p>
+            <a:pPr algn="l">
+              <a:defRPr sz="1300" b="0" i="0">
+                <a:solidFill>
+                  <a:srgbClr val="666666"/>
+                </a:solidFill>
+                <a:latin typeface="Calibri"/>
+              </a:defRPr>
+            </a:pPr>
+            <a:r>
+              <a:t>Lever A: pseudobulk per-TF target (SNR).   Lever B: project the shared direction out of the loss.</a:t>
+            </a:r>
+          </a:p>
+        </p:txBody>
+      </p:sp>
+      <p:pic>
+        <p:nvPicPr>
+          <p:cNvPr id="6" name="Picture 5" descr="fig5_Rsweep.png"/>
+          <p:cNvPicPr>
+            <a:picLocks noChangeAspect="1"/>
+          </p:cNvPicPr>
+          <p:nvPr/>
+        </p:nvPicPr>
+        <p:blipFill>
+          <a:blip r:embed="rId3"/>
+          <a:stretch>
+            <a:fillRect/>
+          </a:stretch>
+        </p:blipFill>
+        <p:spPr>
+          <a:xfrm>
+            <a:off x="457200" y="2011680"/>
+            <a:ext cx="11247120" cy="4498848"/>
+          </a:xfrm>
+          <a:prstGeom prst="rect">
+            <a:avLst/>
+          </a:prstGeom>
+        </p:spPr>
+      </p:pic>
+      <p:sp>
+        <p:nvSpPr>
+          <p:cNvPr id="7" name="TextBox 6"/>
+          <p:cNvSpPr txBox="1"/>
+          <p:nvPr/>
+        </p:nvSpPr>
+        <p:spPr>
+          <a:xfrm>
+            <a:off x="548640" y="6263640"/>
+            <a:ext cx="11338560" cy="731520"/>
           </a:xfrm>
           <a:prstGeom prst="rect">
             <a:avLst/>
@@ -3646,7 +3731,7 @@
               <a:spcAft>
                 <a:spcPts val="600"/>
               </a:spcAft>
-              <a:defRPr sz="1400">
+              <a:defRPr sz="1250">
                 <a:solidFill>
                   <a:srgbClr val="1A1A2E"/>
                 </a:solidFill>
@@ -3654,91 +3739,7 @@
               </a:defRPr>
             </a:pPr>
             <a:r>
-              <a:t>• sparse_con: TRAIN disc 0.93 → held-out 0.62 (+0.31 gap).</a:t>
-            </a:r>
-          </a:p>
-          <a:p>
-            <a:pPr>
-              <a:spcAft>
-                <a:spcPts val="600"/>
-              </a:spcAft>
-              <a:defRPr sz="1400">
-                <a:solidFill>
-                  <a:srgbClr val="1A1A2E"/>
-                </a:solidFill>
-                <a:latin typeface="Calibri"/>
-              </a:defRPr>
-            </a:pPr>
-            <a:r>
-              <a:t>• On seen TFs the model discriminates almost perfectly; it just does not transfer.</a:t>
-            </a:r>
-          </a:p>
-          <a:p>
-            <a:pPr>
-              <a:spcAft>
-                <a:spcPts val="600"/>
-              </a:spcAft>
-              <a:defRPr sz="1400">
-                <a:solidFill>
-                  <a:srgbClr val="1A1A2E"/>
-                </a:solidFill>
-                <a:latin typeface="Calibri"/>
-              </a:defRPr>
-            </a:pPr>
-            <a:r>
-              <a:t>• Shift ‖S‖ stays full-magnitude on unseen TFs → confidently WRONG direction (not mean-regression).</a:t>
-            </a:r>
-          </a:p>
-          <a:p>
-            <a:pPr>
-              <a:spcAft>
-                <a:spcPts val="600"/>
-              </a:spcAft>
-              <a:defRPr sz="1400">
-                <a:solidFill>
-                  <a:srgbClr val="1A1A2E"/>
-                </a:solidFill>
-                <a:latin typeface="Calibri"/>
-              </a:defRPr>
-            </a:pPr>
-            <a:r>
-              <a:t>• pseudobulk arms fit train worse (0.56) and still fail held-out.</a:t>
-            </a:r>
-          </a:p>
-        </p:txBody>
-      </p:sp>
-      <p:sp>
-        <p:nvSpPr>
-          <p:cNvPr id="6" name="TextBox 5"/>
-          <p:cNvSpPr txBox="1"/>
-          <p:nvPr/>
-        </p:nvSpPr>
-        <p:spPr>
-          <a:xfrm>
-            <a:off x="365760" y="6455664"/>
-            <a:ext cx="11430000" cy="320040"/>
-          </a:xfrm>
-          <a:prstGeom prst="rect">
-            <a:avLst/>
-          </a:prstGeom>
-          <a:noFill/>
-        </p:spPr>
-        <p:txBody>
-          <a:bodyPr wrap="square">
-            <a:spAutoFit/>
-          </a:bodyPr>
-          <a:lstStyle/>
-          <a:p>
-            <a:pPr algn="l">
-              <a:defRPr sz="1000" b="0" i="1">
-                <a:solidFill>
-                  <a:srgbClr val="666666"/>
-                </a:solidFill>
-                <a:latin typeface="Calibri"/>
-              </a:defRPr>
-            </a:pPr>
-            <a:r>
-              <a:t>The failure is zero-shot generalization of the TF→effect map — not fitting capacity.</a:t>
+              <a:t>• Pseudobulk (Lever A) lifts crossTF_div 0.03→0.2 and probe_A→0.9 (A engaged) — but disc stays at chance: diverse-but-WRONG. Project-out alone (R3) does nothing. The binding constraint is zero-shot generalization.</a:t>
             </a:r>
           </a:p>
         </p:txBody>
@@ -3844,14 +3845,14 @@
               </a:defRPr>
             </a:pPr>
             <a:r>
-              <a:t>12 · Synthetic control — method sound, A non-identifiable</a:t>
+              <a:t>12 · Generalization is the wall — memorize seen, fail unseen</a:t>
             </a:r>
           </a:p>
         </p:txBody>
       </p:sp>
       <p:pic>
         <p:nvPicPr>
-          <p:cNvPr id="4" name="Picture 3" descr="syn.png"/>
+          <p:cNvPr id="4" name="Picture 3" descr="fig6_train_vs_heldout.png"/>
           <p:cNvPicPr>
             <a:picLocks noChangeAspect="1"/>
           </p:cNvPicPr>
@@ -3865,8 +3866,8 @@
         </p:blipFill>
         <p:spPr>
           <a:xfrm>
-            <a:off x="457200" y="914400"/>
-            <a:ext cx="5486400" cy="1480457"/>
+            <a:off x="457200" y="1051560"/>
+            <a:ext cx="8940800" cy="5029200"/>
           </a:xfrm>
           <a:prstGeom prst="rect">
             <a:avLst/>
@@ -3881,68 +3882,8 @@
         </p:nvSpPr>
         <p:spPr>
           <a:xfrm>
-            <a:off x="6217920" y="1051560"/>
-            <a:ext cx="5669280" cy="365760"/>
-          </a:xfrm>
-          <a:prstGeom prst="rect">
-            <a:avLst/>
-          </a:prstGeom>
-          <a:noFill/>
-        </p:spPr>
-        <p:txBody>
-          <a:bodyPr wrap="square">
-            <a:spAutoFit/>
-          </a:bodyPr>
-          <a:lstStyle/>
-          <a:p>
-            <a:pPr algn="l">
-              <a:defRPr sz="1200" b="0" i="1">
-                <a:solidFill>
-                  <a:srgbClr val="666666"/>
-                </a:solidFill>
-                <a:latin typeface="Calibri"/>
-              </a:defRPr>
-            </a:pPr>
-            <a:r>
-              <a:t>planted A*, sparse shift LINEAR in the descriptor (generalizable)</a:t>
-            </a:r>
-          </a:p>
-        </p:txBody>
-      </p:sp>
-      <p:pic>
-        <p:nvPicPr>
-          <p:cNvPr id="6" name="Picture 5" descr="fig7_synthetic.png"/>
-          <p:cNvPicPr>
-            <a:picLocks noChangeAspect="1"/>
-          </p:cNvPicPr>
-          <p:nvPr/>
-        </p:nvPicPr>
-        <p:blipFill>
-          <a:blip r:embed="rId3"/>
-          <a:stretch>
-            <a:fillRect/>
-          </a:stretch>
-        </p:blipFill>
-        <p:spPr>
-          <a:xfrm>
-            <a:off x="457200" y="1737360"/>
-            <a:ext cx="11247120" cy="4498848"/>
-          </a:xfrm>
-          <a:prstGeom prst="rect">
-            <a:avLst/>
-          </a:prstGeom>
-        </p:spPr>
-      </p:pic>
-      <p:sp>
-        <p:nvSpPr>
-          <p:cNvPr id="7" name="TextBox 6"/>
-          <p:cNvSpPr txBox="1"/>
-          <p:nvPr/>
-        </p:nvSpPr>
-        <p:spPr>
-          <a:xfrm>
-            <a:off x="548640" y="5943600"/>
-            <a:ext cx="11338560" cy="822960"/>
+            <a:off x="7680960" y="1463040"/>
+            <a:ext cx="4206240" cy="4572000"/>
           </a:xfrm>
           <a:prstGeom prst="rect">
             <a:avLst/>
@@ -3959,7 +3900,7 @@
               <a:spcAft>
                 <a:spcPts val="600"/>
               </a:spcAft>
-              <a:defRPr sz="1250">
+              <a:defRPr sz="1400">
                 <a:solidFill>
                   <a:srgbClr val="1A1A2E"/>
                 </a:solidFill>
@@ -3967,7 +3908,91 @@
               </a:defRPr>
             </a:pPr>
             <a:r>
-              <a:t>• Planted A*/D*/generalizable shift: the shift-encoder GENERALIZES (disc 0.66; perturbation-blind localization → 0.90) but graph-recovery AUROC stays at CHANCE (~0.5) — A is non-identifiable (shift+decoder are a sufficient statistic).</a:t>
+              <a:t>• sparse_con: TRAIN disc 0.93 → held-out 0.62 (+0.31 gap).</a:t>
+            </a:r>
+          </a:p>
+          <a:p>
+            <a:pPr>
+              <a:spcAft>
+                <a:spcPts val="600"/>
+              </a:spcAft>
+              <a:defRPr sz="1400">
+                <a:solidFill>
+                  <a:srgbClr val="1A1A2E"/>
+                </a:solidFill>
+                <a:latin typeface="Calibri"/>
+              </a:defRPr>
+            </a:pPr>
+            <a:r>
+              <a:t>• On seen TFs the model discriminates almost perfectly; it just does not transfer.</a:t>
+            </a:r>
+          </a:p>
+          <a:p>
+            <a:pPr>
+              <a:spcAft>
+                <a:spcPts val="600"/>
+              </a:spcAft>
+              <a:defRPr sz="1400">
+                <a:solidFill>
+                  <a:srgbClr val="1A1A2E"/>
+                </a:solidFill>
+                <a:latin typeface="Calibri"/>
+              </a:defRPr>
+            </a:pPr>
+            <a:r>
+              <a:t>• Shift ‖S‖ stays full-magnitude on unseen TFs → confidently WRONG direction (not mean-regression).</a:t>
+            </a:r>
+          </a:p>
+          <a:p>
+            <a:pPr>
+              <a:spcAft>
+                <a:spcPts val="600"/>
+              </a:spcAft>
+              <a:defRPr sz="1400">
+                <a:solidFill>
+                  <a:srgbClr val="1A1A2E"/>
+                </a:solidFill>
+                <a:latin typeface="Calibri"/>
+              </a:defRPr>
+            </a:pPr>
+            <a:r>
+              <a:t>• pseudobulk arms fit train worse (0.56) and still fail held-out.</a:t>
+            </a:r>
+          </a:p>
+        </p:txBody>
+      </p:sp>
+      <p:sp>
+        <p:nvSpPr>
+          <p:cNvPr id="6" name="TextBox 5"/>
+          <p:cNvSpPr txBox="1"/>
+          <p:nvPr/>
+        </p:nvSpPr>
+        <p:spPr>
+          <a:xfrm>
+            <a:off x="365760" y="6455664"/>
+            <a:ext cx="11430000" cy="320040"/>
+          </a:xfrm>
+          <a:prstGeom prst="rect">
+            <a:avLst/>
+          </a:prstGeom>
+          <a:noFill/>
+        </p:spPr>
+        <p:txBody>
+          <a:bodyPr wrap="square">
+            <a:spAutoFit/>
+          </a:bodyPr>
+          <a:lstStyle/>
+          <a:p>
+            <a:pPr algn="l">
+              <a:defRPr sz="1000" b="0" i="1">
+                <a:solidFill>
+                  <a:srgbClr val="666666"/>
+                </a:solidFill>
+                <a:latin typeface="Calibri"/>
+              </a:defRPr>
+            </a:pPr>
+            <a:r>
+              <a:t>The failure is zero-shot generalization of the TF→effect map — not fitting capacity.</a:t>
             </a:r>
           </a:p>
         </p:txBody>
@@ -4073,7 +4098,236 @@
               </a:defRPr>
             </a:pPr>
             <a:r>
-              <a:t>13 · Master results (representative arms, prior-off)</a:t>
+              <a:t>13 · Synthetic control — method sound, A non-identifiable</a:t>
+            </a:r>
+          </a:p>
+        </p:txBody>
+      </p:sp>
+      <p:pic>
+        <p:nvPicPr>
+          <p:cNvPr id="4" name="Picture 3" descr="syn.png"/>
+          <p:cNvPicPr>
+            <a:picLocks noChangeAspect="1"/>
+          </p:cNvPicPr>
+          <p:nvPr/>
+        </p:nvPicPr>
+        <p:blipFill>
+          <a:blip r:embed="rId2"/>
+          <a:stretch>
+            <a:fillRect/>
+          </a:stretch>
+        </p:blipFill>
+        <p:spPr>
+          <a:xfrm>
+            <a:off x="457200" y="914400"/>
+            <a:ext cx="5486400" cy="1480457"/>
+          </a:xfrm>
+          <a:prstGeom prst="rect">
+            <a:avLst/>
+          </a:prstGeom>
+        </p:spPr>
+      </p:pic>
+      <p:sp>
+        <p:nvSpPr>
+          <p:cNvPr id="5" name="TextBox 4"/>
+          <p:cNvSpPr txBox="1"/>
+          <p:nvPr/>
+        </p:nvSpPr>
+        <p:spPr>
+          <a:xfrm>
+            <a:off x="6217920" y="1051560"/>
+            <a:ext cx="5669280" cy="365760"/>
+          </a:xfrm>
+          <a:prstGeom prst="rect">
+            <a:avLst/>
+          </a:prstGeom>
+          <a:noFill/>
+        </p:spPr>
+        <p:txBody>
+          <a:bodyPr wrap="square">
+            <a:spAutoFit/>
+          </a:bodyPr>
+          <a:lstStyle/>
+          <a:p>
+            <a:pPr algn="l">
+              <a:defRPr sz="1200" b="0" i="1">
+                <a:solidFill>
+                  <a:srgbClr val="666666"/>
+                </a:solidFill>
+                <a:latin typeface="Calibri"/>
+              </a:defRPr>
+            </a:pPr>
+            <a:r>
+              <a:t>planted A*, sparse shift LINEAR in the descriptor (generalizable)</a:t>
+            </a:r>
+          </a:p>
+        </p:txBody>
+      </p:sp>
+      <p:pic>
+        <p:nvPicPr>
+          <p:cNvPr id="6" name="Picture 5" descr="fig7_synthetic.png"/>
+          <p:cNvPicPr>
+            <a:picLocks noChangeAspect="1"/>
+          </p:cNvPicPr>
+          <p:nvPr/>
+        </p:nvPicPr>
+        <p:blipFill>
+          <a:blip r:embed="rId3"/>
+          <a:stretch>
+            <a:fillRect/>
+          </a:stretch>
+        </p:blipFill>
+        <p:spPr>
+          <a:xfrm>
+            <a:off x="457200" y="1737360"/>
+            <a:ext cx="11247120" cy="4498848"/>
+          </a:xfrm>
+          <a:prstGeom prst="rect">
+            <a:avLst/>
+          </a:prstGeom>
+        </p:spPr>
+      </p:pic>
+      <p:sp>
+        <p:nvSpPr>
+          <p:cNvPr id="7" name="TextBox 6"/>
+          <p:cNvSpPr txBox="1"/>
+          <p:nvPr/>
+        </p:nvSpPr>
+        <p:spPr>
+          <a:xfrm>
+            <a:off x="548640" y="5943600"/>
+            <a:ext cx="11338560" cy="822960"/>
+          </a:xfrm>
+          <a:prstGeom prst="rect">
+            <a:avLst/>
+          </a:prstGeom>
+          <a:noFill/>
+        </p:spPr>
+        <p:txBody>
+          <a:bodyPr wrap="square">
+            <a:spAutoFit/>
+          </a:bodyPr>
+          <a:lstStyle/>
+          <a:p>
+            <a:pPr>
+              <a:spcAft>
+                <a:spcPts val="600"/>
+              </a:spcAft>
+              <a:defRPr sz="1250">
+                <a:solidFill>
+                  <a:srgbClr val="1A1A2E"/>
+                </a:solidFill>
+                <a:latin typeface="Calibri"/>
+              </a:defRPr>
+            </a:pPr>
+            <a:r>
+              <a:t>• Planted A*/D*/generalizable shift: the shift-encoder GENERALIZES (disc 0.66; perturbation-blind localization → 0.90) but graph-recovery AUROC stays at CHANCE (~0.5) — A is non-identifiable (shift+decoder are a sufficient statistic).</a:t>
+            </a:r>
+          </a:p>
+        </p:txBody>
+      </p:sp>
+    </p:spTree>
+  </p:cSld>
+  <p:clrMapOvr>
+    <a:masterClrMapping/>
+  </p:clrMapOvr>
+</p:sld>
+</file>
+
+<file path=ppt/slides/slide14.xml><?xml version="1.0" encoding="utf-8"?>
+<p:sld xmlns:a="http://schemas.openxmlformats.org/drawingml/2006/main" xmlns:p="http://schemas.openxmlformats.org/presentationml/2006/main" xmlns:r="http://schemas.openxmlformats.org/officeDocument/2006/relationships">
+  <p:cSld>
+    <p:bg>
+      <p:bgPr>
+        <a:solidFill>
+          <a:srgbClr val="FFFFFF"/>
+        </a:solidFill>
+        <a:effectLst/>
+      </p:bgPr>
+    </p:bg>
+    <p:spTree>
+      <p:nvGrpSpPr>
+        <p:cNvPr id="1" name=""/>
+        <p:cNvGrpSpPr/>
+        <p:nvPr/>
+      </p:nvGrpSpPr>
+      <p:grpSpPr/>
+      <p:sp>
+        <p:nvSpPr>
+          <p:cNvPr id="2" name="Rectangle 1"/>
+          <p:cNvSpPr/>
+          <p:nvPr/>
+        </p:nvSpPr>
+        <p:spPr>
+          <a:xfrm>
+            <a:off x="0" y="0"/>
+            <a:ext cx="12191695" cy="777240"/>
+          </a:xfrm>
+          <a:prstGeom prst="rect">
+            <a:avLst/>
+          </a:prstGeom>
+          <a:solidFill>
+            <a:srgbClr val="1A1A2E"/>
+          </a:solidFill>
+          <a:ln>
+            <a:noFill/>
+          </a:ln>
+          <a:effectLst/>
+        </p:spPr>
+        <p:style>
+          <a:lnRef idx="1">
+            <a:schemeClr val="accent1"/>
+          </a:lnRef>
+          <a:fillRef idx="3">
+            <a:schemeClr val="accent1"/>
+          </a:fillRef>
+          <a:effectRef idx="2">
+            <a:schemeClr val="accent1"/>
+          </a:effectRef>
+          <a:fontRef idx="minor">
+            <a:schemeClr val="lt1"/>
+          </a:fontRef>
+        </p:style>
+        <p:txBody>
+          <a:bodyPr rtlCol="0" anchor="ctr"/>
+          <a:lstStyle/>
+          <a:p>
+            <a:pPr algn="ctr"/>
+          </a:p>
+        </p:txBody>
+      </p:sp>
+      <p:sp>
+        <p:nvSpPr>
+          <p:cNvPr id="3" name="TextBox 2"/>
+          <p:cNvSpPr txBox="1"/>
+          <p:nvPr/>
+        </p:nvSpPr>
+        <p:spPr>
+          <a:xfrm>
+            <a:off x="457200" y="137160"/>
+            <a:ext cx="11247120" cy="548640"/>
+          </a:xfrm>
+          <a:prstGeom prst="rect">
+            <a:avLst/>
+          </a:prstGeom>
+          <a:noFill/>
+        </p:spPr>
+        <p:txBody>
+          <a:bodyPr wrap="square">
+            <a:spAutoFit/>
+          </a:bodyPr>
+          <a:lstStyle/>
+          <a:p>
+            <a:pPr algn="l">
+              <a:defRPr sz="2400" b="1" i="0">
+                <a:solidFill>
+                  <a:srgbClr val="FFFFFF"/>
+                </a:solidFill>
+                <a:latin typeface="Calibri"/>
+              </a:defRPr>
+            </a:pPr>
+            <a:r>
+              <a:t>14 · Master results (representative arms, prior-off)</a:t>
             </a:r>
           </a:p>
         </p:txBody>
@@ -5694,7 +5948,7 @@
 </p:sld>
 </file>
 
-<file path=ppt/slides/slide14.xml><?xml version="1.0" encoding="utf-8"?>
+<file path=ppt/slides/slide15.xml><?xml version="1.0" encoding="utf-8"?>
 <p:sld xmlns:a="http://schemas.openxmlformats.org/drawingml/2006/main" xmlns:p="http://schemas.openxmlformats.org/presentationml/2006/main" xmlns:r="http://schemas.openxmlformats.org/officeDocument/2006/relationships">
   <p:cSld>
     <p:bg>
@@ -5787,7 +6041,7 @@
               </a:defRPr>
             </a:pPr>
             <a:r>
-              <a:t>14 · Verdict &amp; the two real levers</a:t>
+              <a:t>15 · Verdict &amp; the two real levers</a:t>
             </a:r>
           </a:p>
         </p:txBody>
@@ -8957,14 +9211,86 @@
               </a:defRPr>
             </a:pPr>
             <a:r>
-              <a:t>6 · Perturbation prediction — nothing beats the prior-off ceiling</a:t>
+              <a:t>6 · Metric definitions &amp; chance levels</a:t>
+            </a:r>
+          </a:p>
+        </p:txBody>
+      </p:sp>
+      <p:sp>
+        <p:nvSpPr>
+          <p:cNvPr id="4" name="TextBox 3"/>
+          <p:cNvSpPr txBox="1"/>
+          <p:nvPr/>
+        </p:nvSpPr>
+        <p:spPr>
+          <a:xfrm>
+            <a:off x="457200" y="868680"/>
+            <a:ext cx="11338560" cy="365760"/>
+          </a:xfrm>
+          <a:prstGeom prst="rect">
+            <a:avLst/>
+          </a:prstGeom>
+          <a:noFill/>
+        </p:spPr>
+        <p:txBody>
+          <a:bodyPr wrap="square">
+            <a:spAutoFit/>
+          </a:bodyPr>
+          <a:lstStyle/>
+          <a:p>
+            <a:pPr algn="l">
+              <a:defRPr sz="1100" b="0" i="1">
+                <a:solidFill>
+                  <a:srgbClr val="666666"/>
+                </a:solidFill>
+                <a:latin typeface="Calibri"/>
+              </a:defRPr>
+            </a:pPr>
+            <a:r>
+              <a:t>c(a,b) = mean-centered cosine.   r̂=pred−drift, r=obs−drift.   Δ̂(A)=do-op prediction under adjacency A  (A=0 zeroed, Aπ column-shuffled).</a:t>
+            </a:r>
+          </a:p>
+        </p:txBody>
+      </p:sp>
+      <p:sp>
+        <p:nvSpPr>
+          <p:cNvPr id="5" name="TextBox 4"/>
+          <p:cNvSpPr txBox="1"/>
+          <p:nvPr/>
+        </p:nvSpPr>
+        <p:spPr>
+          <a:xfrm>
+            <a:off x="457200" y="1325880"/>
+            <a:ext cx="5486400" cy="365760"/>
+          </a:xfrm>
+          <a:prstGeom prst="rect">
+            <a:avLst/>
+          </a:prstGeom>
+          <a:noFill/>
+        </p:spPr>
+        <p:txBody>
+          <a:bodyPr wrap="square">
+            <a:spAutoFit/>
+          </a:bodyPr>
+          <a:lstStyle/>
+          <a:p>
+            <a:pPr>
+              <a:defRPr sz="1700" b="1">
+                <a:solidFill>
+                  <a:srgbClr val="C0392B"/>
+                </a:solidFill>
+                <a:latin typeface="Calibri"/>
+              </a:defRPr>
+            </a:pPr>
+            <a:r>
+              <a:t>Prediction   (chance 0.5)</a:t>
             </a:r>
           </a:p>
         </p:txBody>
       </p:sp>
       <p:pic>
         <p:nvPicPr>
-          <p:cNvPr id="4" name="Picture 3" descr="fig1_prediction_ladder.png"/>
+          <p:cNvPr id="6" name="Picture 5" descr="d_disc.png"/>
           <p:cNvPicPr>
             <a:picLocks noChangeAspect="1"/>
           </p:cNvPicPr>
@@ -8978,24 +9304,48 @@
         </p:blipFill>
         <p:spPr>
           <a:xfrm>
-            <a:off x="457200" y="960120"/>
-            <a:ext cx="6294120" cy="5394960"/>
+            <a:off x="548640" y="1737360"/>
+            <a:ext cx="5577840" cy="1420188"/>
           </a:xfrm>
           <a:prstGeom prst="rect">
             <a:avLst/>
           </a:prstGeom>
         </p:spPr>
       </p:pic>
-      <p:sp>
-        <p:nvSpPr>
-          <p:cNvPr id="5" name="TextBox 4"/>
+      <p:pic>
+        <p:nvPicPr>
+          <p:cNvPr id="7" name="Picture 6" descr="d_pear.png"/>
+          <p:cNvPicPr>
+            <a:picLocks noChangeAspect="1"/>
+          </p:cNvPicPr>
+          <p:nvPr/>
+        </p:nvPicPr>
+        <p:blipFill>
+          <a:blip r:embed="rId3"/>
+          <a:stretch>
+            <a:fillRect/>
+          </a:stretch>
+        </p:blipFill>
+        <p:spPr>
+          <a:xfrm>
+            <a:off x="548640" y="2468880"/>
+            <a:ext cx="3200400" cy="1164703"/>
+          </a:xfrm>
+          <a:prstGeom prst="rect">
+            <a:avLst/>
+          </a:prstGeom>
+        </p:spPr>
+      </p:pic>
+      <p:sp>
+        <p:nvSpPr>
+          <p:cNvPr id="8" name="TextBox 7"/>
           <p:cNvSpPr txBox="1"/>
           <p:nvPr/>
         </p:nvSpPr>
         <p:spPr>
           <a:xfrm>
-            <a:off x="7680960" y="1371600"/>
-            <a:ext cx="4206240" cy="4572000"/>
+            <a:off x="457200" y="3154680"/>
+            <a:ext cx="5486400" cy="365760"/>
           </a:xfrm>
           <a:prstGeom prst="rect">
             <a:avLst/>
@@ -9009,96 +9359,77 @@
           <a:lstStyle/>
           <a:p>
             <a:pPr>
-              <a:spcAft>
-                <a:spcPts val="600"/>
-              </a:spcAft>
-              <a:defRPr sz="1400">
-                <a:solidFill>
-                  <a:srgbClr val="1A1A2E"/>
+              <a:defRPr sz="1700" b="1">
+                <a:solidFill>
+                  <a:srgbClr val="2171B5"/>
                 </a:solidFill>
                 <a:latin typeface="Calibri"/>
               </a:defRPr>
             </a:pPr>
             <a:r>
-              <a:t>• Best = prior-off sparse_con 0.639 ≈ exp19 epsmix ceiling 0.647.</a:t>
-            </a:r>
-          </a:p>
-          <a:p>
-            <a:pPr>
-              <a:spcAft>
-                <a:spcPts val="600"/>
-              </a:spcAft>
-              <a:defRPr sz="1400">
-                <a:solidFill>
-                  <a:srgbClr val="1A1A2E"/>
-                </a:solidFill>
-                <a:latin typeface="Calibri"/>
-              </a:defRPr>
-            </a:pPr>
-            <a:r>
-              <a:t>• Turning the CollecTRI PRIOR OFF is the only change that helped (+0.05).</a:t>
-            </a:r>
-          </a:p>
-          <a:p>
-            <a:pPr>
-              <a:spcAft>
-                <a:spcPts val="600"/>
-              </a:spcAft>
-              <a:defRPr sz="1400">
-                <a:solidFill>
-                  <a:srgbClr val="1A1A2E"/>
-                </a:solidFill>
-                <a:latin typeface="Calibri"/>
-              </a:defRPr>
-            </a:pPr>
-            <a:r>
-              <a:t>• whiten / resid / all / frozen arms COLLAPSE to chance (0.50).</a:t>
-            </a:r>
-          </a:p>
-          <a:p>
-            <a:pPr>
-              <a:spcAft>
-                <a:spcPts val="600"/>
-              </a:spcAft>
-              <a:defRPr sz="1400">
-                <a:solidFill>
-                  <a:srgbClr val="1A1A2E"/>
-                </a:solidFill>
-                <a:latin typeface="Calibri"/>
-              </a:defRPr>
-            </a:pPr>
-            <a:r>
-              <a:t>• staged-L0 and nonlinear-SCM are flat-to-worse.</a:t>
-            </a:r>
-          </a:p>
-          <a:p>
-            <a:pPr>
-              <a:spcAft>
-                <a:spcPts val="600"/>
-              </a:spcAft>
-              <a:defRPr sz="1400">
-                <a:solidFill>
-                  <a:srgbClr val="1A1A2E"/>
-                </a:solidFill>
-                <a:latin typeface="Calibri"/>
-              </a:defRPr>
-            </a:pPr>
-            <a:r>
-              <a:t>• Net: no architectural/objective fix beat a simple prior-off shift+decoder.</a:t>
-            </a:r>
-          </a:p>
-        </p:txBody>
-      </p:sp>
-      <p:sp>
-        <p:nvSpPr>
-          <p:cNvPr id="6" name="TextBox 5"/>
+              <a:t>Causality — is A load-bearing?</a:t>
+            </a:r>
+          </a:p>
+        </p:txBody>
+      </p:sp>
+      <p:pic>
+        <p:nvPicPr>
+          <p:cNvPr id="9" name="Picture 8" descr="d_agap.png"/>
+          <p:cNvPicPr>
+            <a:picLocks noChangeAspect="1"/>
+          </p:cNvPicPr>
+          <p:nvPr/>
+        </p:nvPicPr>
+        <p:blipFill>
+          <a:blip r:embed="rId4"/>
+          <a:stretch>
+            <a:fillRect/>
+          </a:stretch>
+        </p:blipFill>
+        <p:spPr>
+          <a:xfrm>
+            <a:off x="548640" y="3566160"/>
+            <a:ext cx="6126480" cy="1680824"/>
+          </a:xfrm>
+          <a:prstGeom prst="rect">
+            <a:avLst/>
+          </a:prstGeom>
+        </p:spPr>
+      </p:pic>
+      <p:pic>
+        <p:nvPicPr>
+          <p:cNvPr id="10" name="Picture 9" descr="d_probeA.png"/>
+          <p:cNvPicPr>
+            <a:picLocks noChangeAspect="1"/>
+          </p:cNvPicPr>
+          <p:nvPr/>
+        </p:nvPicPr>
+        <p:blipFill>
+          <a:blip r:embed="rId5"/>
+          <a:stretch>
+            <a:fillRect/>
+          </a:stretch>
+        </p:blipFill>
+        <p:spPr>
+          <a:xfrm>
+            <a:off x="548640" y="4572000"/>
+            <a:ext cx="5120640" cy="1437446"/>
+          </a:xfrm>
+          <a:prstGeom prst="rect">
+            <a:avLst/>
+          </a:prstGeom>
+        </p:spPr>
+      </p:pic>
+      <p:sp>
+        <p:nvSpPr>
+          <p:cNvPr id="11" name="TextBox 10"/>
           <p:cNvSpPr txBox="1"/>
           <p:nvPr/>
         </p:nvSpPr>
         <p:spPr>
           <a:xfrm>
-            <a:off x="365760" y="6455664"/>
-            <a:ext cx="11430000" cy="320040"/>
+            <a:off x="6446520" y="1325880"/>
+            <a:ext cx="5486400" cy="365760"/>
           </a:xfrm>
           <a:prstGeom prst="rect">
             <a:avLst/>
@@ -9111,16 +9442,254 @@
           </a:bodyPr>
           <a:lstStyle/>
           <a:p>
+            <a:pPr>
+              <a:defRPr sz="1700" b="1">
+                <a:solidFill>
+                  <a:srgbClr val="6B3FA0"/>
+                </a:solidFill>
+                <a:latin typeface="Calibri"/>
+              </a:defRPr>
+            </a:pPr>
+            <a:r>
+              <a:t>Mechanism</a:t>
+            </a:r>
+          </a:p>
+        </p:txBody>
+      </p:sp>
+      <p:pic>
+        <p:nvPicPr>
+          <p:cNvPr id="12" name="Picture 11" descr="d_dperm.png"/>
+          <p:cNvPicPr>
+            <a:picLocks noChangeAspect="1"/>
+          </p:cNvPicPr>
+          <p:nvPr/>
+        </p:nvPicPr>
+        <p:blipFill>
+          <a:blip r:embed="rId6"/>
+          <a:stretch>
+            <a:fillRect/>
+          </a:stretch>
+        </p:blipFill>
+        <p:spPr>
+          <a:xfrm>
+            <a:off x="6537960" y="1737360"/>
+            <a:ext cx="5212080" cy="1369072"/>
+          </a:xfrm>
+          <a:prstGeom prst="rect">
+            <a:avLst/>
+          </a:prstGeom>
+        </p:spPr>
+      </p:pic>
+      <p:pic>
+        <p:nvPicPr>
+          <p:cNvPr id="13" name="Picture 12" descr="d_cross.png"/>
+          <p:cNvPicPr>
+            <a:picLocks noChangeAspect="1"/>
+          </p:cNvPicPr>
+          <p:nvPr/>
+        </p:nvPicPr>
+        <p:blipFill>
+          <a:blip r:embed="rId7"/>
+          <a:stretch>
+            <a:fillRect/>
+          </a:stretch>
+        </p:blipFill>
+        <p:spPr>
+          <a:xfrm>
+            <a:off x="6537960" y="2468880"/>
+            <a:ext cx="4754880" cy="1363092"/>
+          </a:xfrm>
+          <a:prstGeom prst="rect">
+            <a:avLst/>
+          </a:prstGeom>
+        </p:spPr>
+      </p:pic>
+      <p:sp>
+        <p:nvSpPr>
+          <p:cNvPr id="14" name="TextBox 13"/>
+          <p:cNvSpPr txBox="1"/>
+          <p:nvPr/>
+        </p:nvSpPr>
+        <p:spPr>
+          <a:xfrm>
+            <a:off x="6446520" y="3154680"/>
+            <a:ext cx="5486400" cy="365760"/>
+          </a:xfrm>
+          <a:prstGeom prst="rect">
+            <a:avLst/>
+          </a:prstGeom>
+          <a:noFill/>
+        </p:spPr>
+        <p:txBody>
+          <a:bodyPr wrap="square">
+            <a:spAutoFit/>
+          </a:bodyPr>
+          <a:lstStyle/>
+          <a:p>
+            <a:pPr>
+              <a:defRPr sz="1700" b="1">
+                <a:solidFill>
+                  <a:srgbClr val="27AE60"/>
+                </a:solidFill>
+                <a:latin typeface="Calibri"/>
+              </a:defRPr>
+            </a:pPr>
+            <a:r>
+              <a:t>Biology  (AUROC, prior-free)</a:t>
+            </a:r>
+          </a:p>
+        </p:txBody>
+      </p:sp>
+      <p:pic>
+        <p:nvPicPr>
+          <p:cNvPr id="15" name="Picture 14" descr="d_grn.png"/>
+          <p:cNvPicPr>
+            <a:picLocks noChangeAspect="1"/>
+          </p:cNvPicPr>
+          <p:nvPr/>
+        </p:nvPicPr>
+        <p:blipFill>
+          <a:blip r:embed="rId8"/>
+          <a:stretch>
+            <a:fillRect/>
+          </a:stretch>
+        </p:blipFill>
+        <p:spPr>
+          <a:xfrm>
+            <a:off x="6537960" y="3566160"/>
+            <a:ext cx="5394960" cy="1529779"/>
+          </a:xfrm>
+          <a:prstGeom prst="rect">
+            <a:avLst/>
+          </a:prstGeom>
+        </p:spPr>
+      </p:pic>
+      <p:pic>
+        <p:nvPicPr>
+          <p:cNvPr id="16" name="Picture 15" descr="d_fate.png"/>
+          <p:cNvPicPr>
+            <a:picLocks noChangeAspect="1"/>
+          </p:cNvPicPr>
+          <p:nvPr/>
+        </p:nvPicPr>
+        <p:blipFill>
+          <a:blip r:embed="rId9"/>
+          <a:stretch>
+            <a:fillRect/>
+          </a:stretch>
+        </p:blipFill>
+        <p:spPr>
+          <a:xfrm>
+            <a:off x="6537960" y="4114800"/>
+            <a:ext cx="5120640" cy="1528954"/>
+          </a:xfrm>
+          <a:prstGeom prst="rect">
+            <a:avLst/>
+          </a:prstGeom>
+        </p:spPr>
+      </p:pic>
+      <p:pic>
+        <p:nvPicPr>
+          <p:cNvPr id="17" name="Picture 16" descr="d_graph.png"/>
+          <p:cNvPicPr>
+            <a:picLocks noChangeAspect="1"/>
+          </p:cNvPicPr>
+          <p:nvPr/>
+        </p:nvPicPr>
+        <p:blipFill>
+          <a:blip r:embed="rId10"/>
+          <a:stretch>
+            <a:fillRect/>
+          </a:stretch>
+        </p:blipFill>
+        <p:spPr>
+          <a:xfrm>
+            <a:off x="6537960" y="4663440"/>
+            <a:ext cx="5120640" cy="1505023"/>
+          </a:xfrm>
+          <a:prstGeom prst="rect">
+            <a:avLst/>
+          </a:prstGeom>
+        </p:spPr>
+      </p:pic>
+      <p:sp>
+        <p:nvSpPr>
+          <p:cNvPr id="18" name="Rounded Rectangle 17"/>
+          <p:cNvSpPr/>
+          <p:nvPr/>
+        </p:nvSpPr>
+        <p:spPr>
+          <a:xfrm>
+            <a:off x="457200" y="5440680"/>
+            <a:ext cx="11338560" cy="960120"/>
+          </a:xfrm>
+          <a:prstGeom prst="roundRect">
+            <a:avLst/>
+          </a:prstGeom>
+          <a:solidFill>
+            <a:srgbClr val="F5F5EA"/>
+          </a:solidFill>
+          <a:ln w="19050">
+            <a:solidFill>
+              <a:srgbClr val="D9821E"/>
+            </a:solidFill>
+          </a:ln>
+          <a:effectLst/>
+        </p:spPr>
+        <p:style>
+          <a:lnRef idx="1">
+            <a:schemeClr val="accent1"/>
+          </a:lnRef>
+          <a:fillRef idx="3">
+            <a:schemeClr val="accent1"/>
+          </a:fillRef>
+          <a:effectRef idx="2">
+            <a:schemeClr val="accent1"/>
+          </a:effectRef>
+          <a:fontRef idx="minor">
+            <a:schemeClr val="lt1"/>
+          </a:fontRef>
+        </p:style>
+        <p:txBody>
+          <a:bodyPr rtlCol="0" anchor="ctr"/>
+          <a:lstStyle/>
+          <a:p>
+            <a:pPr algn="ctr"/>
+          </a:p>
+        </p:txBody>
+      </p:sp>
+      <p:sp>
+        <p:nvSpPr>
+          <p:cNvPr id="19" name="TextBox 18"/>
+          <p:cNvSpPr txBox="1"/>
+          <p:nvPr/>
+        </p:nvSpPr>
+        <p:spPr>
+          <a:xfrm>
+            <a:off x="658368" y="5532120"/>
+            <a:ext cx="10972800" cy="868680"/>
+          </a:xfrm>
+          <a:prstGeom prst="rect">
+            <a:avLst/>
+          </a:prstGeom>
+          <a:noFill/>
+        </p:spPr>
+        <p:txBody>
+          <a:bodyPr wrap="square">
+            <a:spAutoFit/>
+          </a:bodyPr>
+          <a:lstStyle/>
+          <a:p>
             <a:pPr algn="l">
-              <a:defRPr sz="1000" b="0" i="1">
-                <a:solidFill>
-                  <a:srgbClr val="666666"/>
+              <a:defRPr sz="1150" b="1" i="0">
+                <a:solidFill>
+                  <a:srgbClr val="1A1A2E"/>
                 </a:solidFill>
                 <a:latin typeface="Calibri"/>
               </a:defRPr>
             </a:pPr>
             <a:r>
-              <a:t>Held-out zero-shot TFs; disc_resid, chance 0.5, exp19 ceiling 0.647.</a:t>
+              <a:t>KEY DISTINCTION: probe_A = “A is USED” (output changes if A removed);  S_Agap = “A is USEFUL” (drift-removed prediction improves). Finding: probe_A can be 0.8 while S_Agap≈0 — used, not useful.   Note: grn_dag_sweep’s “disc” column = retrieval-top-1 (chance 1/T≈0.006), NOT disc_resid (chance 0.5).</a:t>
             </a:r>
           </a:p>
         </p:txBody>
@@ -9226,14 +9795,14 @@
               </a:defRPr>
             </a:pPr>
             <a:r>
-              <a:t>7 · Causality — A is not load-bearing</a:t>
+              <a:t>7 · Perturbation prediction — nothing beats the prior-off ceiling</a:t>
             </a:r>
           </a:p>
         </p:txBody>
       </p:sp>
       <p:pic>
         <p:nvPicPr>
-          <p:cNvPr id="4" name="Picture 3" descr="fig2_causality_Agap.png"/>
+          <p:cNvPr id="4" name="Picture 3" descr="fig1_prediction_ladder.png"/>
           <p:cNvPicPr>
             <a:picLocks noChangeAspect="1"/>
           </p:cNvPicPr>
@@ -9247,8 +9816,8 @@
         </p:blipFill>
         <p:spPr>
           <a:xfrm>
-            <a:off x="457200" y="1005840"/>
-            <a:ext cx="11247120" cy="4396601"/>
+            <a:off x="457200" y="960120"/>
+            <a:ext cx="6294120" cy="5394960"/>
           </a:xfrm>
           <a:prstGeom prst="rect">
             <a:avLst/>
@@ -9263,8 +9832,8 @@
         </p:nvSpPr>
         <p:spPr>
           <a:xfrm>
-            <a:off x="548640" y="5669280"/>
-            <a:ext cx="11338560" cy="914400"/>
+            <a:off x="7680960" y="1371600"/>
+            <a:ext cx="4206240" cy="4572000"/>
           </a:xfrm>
           <a:prstGeom prst="rect">
             <a:avLst/>
@@ -9281,7 +9850,7 @@
               <a:spcAft>
                 <a:spcPts val="600"/>
               </a:spcAft>
-              <a:defRPr sz="1350">
+              <a:defRPr sz="1400">
                 <a:solidFill>
                   <a:srgbClr val="1A1A2E"/>
                 </a:solidFill>
@@ -9289,7 +9858,107 @@
               </a:defRPr>
             </a:pPr>
             <a:r>
-              <a:t>• real-A ≈ zero-A ≈ shuffled-A on drift-removed prediction; A_gap ≈ 0 for every prior-off arm (±0.05). Removing or shuffling A barely changes the match — A carries no predictive causal structure.</a:t>
+              <a:t>• Best = prior-off sparse_con 0.639 ≈ exp19 epsmix ceiling 0.647.</a:t>
+            </a:r>
+          </a:p>
+          <a:p>
+            <a:pPr>
+              <a:spcAft>
+                <a:spcPts val="600"/>
+              </a:spcAft>
+              <a:defRPr sz="1400">
+                <a:solidFill>
+                  <a:srgbClr val="1A1A2E"/>
+                </a:solidFill>
+                <a:latin typeface="Calibri"/>
+              </a:defRPr>
+            </a:pPr>
+            <a:r>
+              <a:t>• Turning the CollecTRI PRIOR OFF is the only change that helped (+0.05).</a:t>
+            </a:r>
+          </a:p>
+          <a:p>
+            <a:pPr>
+              <a:spcAft>
+                <a:spcPts val="600"/>
+              </a:spcAft>
+              <a:defRPr sz="1400">
+                <a:solidFill>
+                  <a:srgbClr val="1A1A2E"/>
+                </a:solidFill>
+                <a:latin typeface="Calibri"/>
+              </a:defRPr>
+            </a:pPr>
+            <a:r>
+              <a:t>• whiten / resid / all / frozen arms COLLAPSE to chance (0.50).</a:t>
+            </a:r>
+          </a:p>
+          <a:p>
+            <a:pPr>
+              <a:spcAft>
+                <a:spcPts val="600"/>
+              </a:spcAft>
+              <a:defRPr sz="1400">
+                <a:solidFill>
+                  <a:srgbClr val="1A1A2E"/>
+                </a:solidFill>
+                <a:latin typeface="Calibri"/>
+              </a:defRPr>
+            </a:pPr>
+            <a:r>
+              <a:t>• staged-L0 and nonlinear-SCM are flat-to-worse.</a:t>
+            </a:r>
+          </a:p>
+          <a:p>
+            <a:pPr>
+              <a:spcAft>
+                <a:spcPts val="600"/>
+              </a:spcAft>
+              <a:defRPr sz="1400">
+                <a:solidFill>
+                  <a:srgbClr val="1A1A2E"/>
+                </a:solidFill>
+                <a:latin typeface="Calibri"/>
+              </a:defRPr>
+            </a:pPr>
+            <a:r>
+              <a:t>• Net: no architectural/objective fix beat a simple prior-off shift+decoder.</a:t>
+            </a:r>
+          </a:p>
+        </p:txBody>
+      </p:sp>
+      <p:sp>
+        <p:nvSpPr>
+          <p:cNvPr id="6" name="TextBox 5"/>
+          <p:cNvSpPr txBox="1"/>
+          <p:nvPr/>
+        </p:nvSpPr>
+        <p:spPr>
+          <a:xfrm>
+            <a:off x="365760" y="6455664"/>
+            <a:ext cx="11430000" cy="320040"/>
+          </a:xfrm>
+          <a:prstGeom prst="rect">
+            <a:avLst/>
+          </a:prstGeom>
+          <a:noFill/>
+        </p:spPr>
+        <p:txBody>
+          <a:bodyPr wrap="square">
+            <a:spAutoFit/>
+          </a:bodyPr>
+          <a:lstStyle/>
+          <a:p>
+            <a:pPr algn="l">
+              <a:defRPr sz="1000" b="0" i="1">
+                <a:solidFill>
+                  <a:srgbClr val="666666"/>
+                </a:solidFill>
+                <a:latin typeface="Calibri"/>
+              </a:defRPr>
+            </a:pPr>
+            <a:r>
+              <a:t>Held-out zero-shot TFs; disc_resid, chance 0.5, exp19 ceiling 0.647.</a:t>
             </a:r>
           </a:p>
         </p:txBody>
@@ -9395,14 +10064,14 @@
               </a:defRPr>
             </a:pPr>
             <a:r>
-              <a:t>8 · Mechanism — decoder absorbs the operator; predictions collapse</a:t>
+              <a:t>8 · Causality — A is not load-bearing</a:t>
             </a:r>
           </a:p>
         </p:txBody>
       </p:sp>
       <p:pic>
         <p:nvPicPr>
-          <p:cNvPr id="4" name="Picture 3" descr="fig3_mechanism.png"/>
+          <p:cNvPr id="4" name="Picture 3" descr="fig2_causality_Agap.png"/>
           <p:cNvPicPr>
             <a:picLocks noChangeAspect="1"/>
           </p:cNvPicPr>
@@ -9416,8 +10085,8 @@
         </p:blipFill>
         <p:spPr>
           <a:xfrm>
-            <a:off x="457200" y="960120"/>
-            <a:ext cx="9231464" cy="4937760"/>
+            <a:off x="457200" y="1005840"/>
+            <a:ext cx="11247120" cy="4396601"/>
           </a:xfrm>
           <a:prstGeom prst="rect">
             <a:avLst/>
@@ -9432,68 +10101,8 @@
         </p:nvSpPr>
         <p:spPr>
           <a:xfrm>
-            <a:off x="8229600" y="1188720"/>
-            <a:ext cx="3749039" cy="365760"/>
-          </a:xfrm>
-          <a:prstGeom prst="rect">
-            <a:avLst/>
-          </a:prstGeom>
-          <a:noFill/>
-        </p:spPr>
-        <p:txBody>
-          <a:bodyPr wrap="square">
-            <a:spAutoFit/>
-          </a:bodyPr>
-          <a:lstStyle/>
-          <a:p>
-            <a:pPr>
-              <a:defRPr sz="1700" b="1">
-                <a:solidFill>
-                  <a:srgbClr val="0B3D91"/>
-                </a:solidFill>
-                <a:latin typeface="Calibri"/>
-              </a:defRPr>
-            </a:pPr>
-            <a:r>
-              <a:t>Why A is redundant</a:t>
-            </a:r>
-          </a:p>
-        </p:txBody>
-      </p:sp>
-      <p:pic>
-        <p:nvPicPr>
-          <p:cNvPr id="6" name="Picture 5" descr="absorb2.png"/>
-          <p:cNvPicPr>
-            <a:picLocks noChangeAspect="1"/>
-          </p:cNvPicPr>
-          <p:nvPr/>
-        </p:nvPicPr>
-        <p:blipFill>
-          <a:blip r:embed="rId3"/>
-          <a:stretch>
-            <a:fillRect/>
-          </a:stretch>
-        </p:blipFill>
-        <p:spPr>
-          <a:xfrm>
-            <a:off x="8229600" y="1645920"/>
-            <a:ext cx="1828800" cy="1230468"/>
-          </a:xfrm>
-          <a:prstGeom prst="rect">
-            <a:avLst/>
-          </a:prstGeom>
-        </p:spPr>
-      </p:pic>
-      <p:sp>
-        <p:nvSpPr>
-          <p:cNvPr id="7" name="TextBox 6"/>
-          <p:cNvSpPr txBox="1"/>
-          <p:nvPr/>
-        </p:nvSpPr>
-        <p:spPr>
-          <a:xfrm>
-            <a:off x="8229600" y="2286000"/>
-            <a:ext cx="3749039" cy="3840480"/>
+            <a:off x="548640" y="5669280"/>
+            <a:ext cx="11338560" cy="914400"/>
           </a:xfrm>
           <a:prstGeom prst="rect">
             <a:avLst/>
@@ -9510,7 +10119,7 @@
               <a:spcAft>
                 <a:spcPts val="600"/>
               </a:spcAft>
-              <a:defRPr sz="1300">
+              <a:defRPr sz="1350">
                 <a:solidFill>
                   <a:srgbClr val="1A1A2E"/>
                 </a:solidFill>
@@ -9518,91 +10127,7 @@
               </a:defRPr>
             </a:pPr>
             <a:r>
-              <a:t>• probe_Dperm ≈ 1.0: shuffling D destroys the output → D carries the gene pattern.</a:t>
-            </a:r>
-          </a:p>
-          <a:p>
-            <a:pPr>
-              <a:spcAft>
-                <a:spcPts val="600"/>
-              </a:spcAft>
-              <a:defRPr sz="1300">
-                <a:solidFill>
-                  <a:srgbClr val="1A1A2E"/>
-                </a:solidFill>
-                <a:latin typeface="Calibri"/>
-              </a:defRPr>
-            </a:pPr>
-            <a:r>
-              <a:t>• probe_A ≤ 0.16 (soft gate): A a minor add-on.</a:t>
-            </a:r>
-          </a:p>
-          <a:p>
-            <a:pPr>
-              <a:spcAft>
-                <a:spcPts val="600"/>
-              </a:spcAft>
-              <a:defRPr sz="1300">
-                <a:solidFill>
-                  <a:srgbClr val="1A1A2E"/>
-                </a:solidFill>
-                <a:latin typeface="Calibri"/>
-              </a:defRPr>
-            </a:pPr>
-            <a:r>
-              <a:t>• crossTF_div ≈ 0.02: ~99% identical predictions across TFs = mode collapse.</a:t>
-            </a:r>
-          </a:p>
-          <a:p>
-            <a:pPr>
-              <a:spcAft>
-                <a:spcPts val="600"/>
-              </a:spcAft>
-              <a:defRPr sz="1300">
-                <a:solidFill>
-                  <a:srgbClr val="1A1A2E"/>
-                </a:solidFill>
-                <a:latin typeface="Calibri"/>
-              </a:defRPr>
-            </a:pPr>
-            <a:r>
-              <a:t>• A single scalar shift_scale absorbs 27–47% of the pert-loss gradient.</a:t>
-            </a:r>
-          </a:p>
-        </p:txBody>
-      </p:sp>
-      <p:sp>
-        <p:nvSpPr>
-          <p:cNvPr id="8" name="TextBox 7"/>
-          <p:cNvSpPr txBox="1"/>
-          <p:nvPr/>
-        </p:nvSpPr>
-        <p:spPr>
-          <a:xfrm>
-            <a:off x="365760" y="6455664"/>
-            <a:ext cx="11430000" cy="320040"/>
-          </a:xfrm>
-          <a:prstGeom prst="rect">
-            <a:avLst/>
-          </a:prstGeom>
-          <a:noFill/>
-        </p:spPr>
-        <p:txBody>
-          <a:bodyPr wrap="square">
-            <a:spAutoFit/>
-          </a:bodyPr>
-          <a:lstStyle/>
-          <a:p>
-            <a:pPr algn="l">
-              <a:defRPr sz="1000" b="0" i="1">
-                <a:solidFill>
-                  <a:srgbClr val="666666"/>
-                </a:solidFill>
-                <a:latin typeface="Calibri"/>
-              </a:defRPr>
-            </a:pPr>
-            <a:r>
-              <a:t>The shift is load-bearing for MAGNITUDE, not identity; the decoder carries the gene-space pattern.</a:t>
+              <a:t>• real-A ≈ zero-A ≈ shuffled-A on drift-removed prediction; A_gap ≈ 0 for every prior-off arm (±0.05). Removing or shuffling A barely changes the match — A carries no predictive causal structure.</a:t>
             </a:r>
           </a:p>
         </p:txBody>
@@ -9708,14 +10233,14 @@
               </a:defRPr>
             </a:pPr>
             <a:r>
-              <a:t>9 · Biology — the projected GRN is prior memorization</a:t>
+              <a:t>9 · Mechanism — decoder absorbs the operator; predictions collapse</a:t>
             </a:r>
           </a:p>
         </p:txBody>
       </p:sp>
       <p:pic>
         <p:nvPicPr>
-          <p:cNvPr id="4" name="Picture 3" descr="fig4_biology_grn.png"/>
+          <p:cNvPr id="4" name="Picture 3" descr="fig3_mechanism.png"/>
           <p:cNvPicPr>
             <a:picLocks noChangeAspect="1"/>
           </p:cNvPicPr>
@@ -9745,8 +10270,68 @@
         </p:nvSpPr>
         <p:spPr>
           <a:xfrm>
-            <a:off x="8229600" y="1371600"/>
-            <a:ext cx="3749039" cy="4572000"/>
+            <a:off x="8229600" y="1188720"/>
+            <a:ext cx="3749039" cy="365760"/>
+          </a:xfrm>
+          <a:prstGeom prst="rect">
+            <a:avLst/>
+          </a:prstGeom>
+          <a:noFill/>
+        </p:spPr>
+        <p:txBody>
+          <a:bodyPr wrap="square">
+            <a:spAutoFit/>
+          </a:bodyPr>
+          <a:lstStyle/>
+          <a:p>
+            <a:pPr>
+              <a:defRPr sz="1700" b="1">
+                <a:solidFill>
+                  <a:srgbClr val="0B3D91"/>
+                </a:solidFill>
+                <a:latin typeface="Calibri"/>
+              </a:defRPr>
+            </a:pPr>
+            <a:r>
+              <a:t>Why A is redundant</a:t>
+            </a:r>
+          </a:p>
+        </p:txBody>
+      </p:sp>
+      <p:pic>
+        <p:nvPicPr>
+          <p:cNvPr id="6" name="Picture 5" descr="absorb2.png"/>
+          <p:cNvPicPr>
+            <a:picLocks noChangeAspect="1"/>
+          </p:cNvPicPr>
+          <p:nvPr/>
+        </p:nvPicPr>
+        <p:blipFill>
+          <a:blip r:embed="rId3"/>
+          <a:stretch>
+            <a:fillRect/>
+          </a:stretch>
+        </p:blipFill>
+        <p:spPr>
+          <a:xfrm>
+            <a:off x="8229600" y="1645920"/>
+            <a:ext cx="1828800" cy="1230468"/>
+          </a:xfrm>
+          <a:prstGeom prst="rect">
+            <a:avLst/>
+          </a:prstGeom>
+        </p:spPr>
+      </p:pic>
+      <p:sp>
+        <p:nvSpPr>
+          <p:cNvPr id="7" name="TextBox 6"/>
+          <p:cNvSpPr txBox="1"/>
+          <p:nvPr/>
+        </p:nvSpPr>
+        <p:spPr>
+          <a:xfrm>
+            <a:off x="8229600" y="2286000"/>
+            <a:ext cx="3749039" cy="3840480"/>
           </a:xfrm>
           <a:prstGeom prst="rect">
             <a:avLst/>
@@ -9763,7 +10348,7 @@
               <a:spcAft>
                 <a:spcPts val="600"/>
               </a:spcAft>
-              <a:defRPr sz="1350">
+              <a:defRPr sz="1300">
                 <a:solidFill>
                   <a:srgbClr val="1A1A2E"/>
                 </a:solidFill>
@@ -9771,7 +10356,7 @@
               </a:defRPr>
             </a:pPr>
             <a:r>
-              <a:t>• CollecTRI AUROC 0.98 (prior ON) → 0.57 (prior OFF) = co-expression floor.</a:t>
+              <a:t>• probe_Dperm ≈ 1.0: shuffling D destroys the output → D carries the gene pattern.</a:t>
             </a:r>
           </a:p>
           <a:p>
@@ -9779,7 +10364,7 @@
               <a:spcAft>
                 <a:spcPts val="600"/>
               </a:spcAft>
-              <a:defRPr sz="1350">
+              <a:defRPr sz="1300">
                 <a:solidFill>
                   <a:srgbClr val="1A1A2E"/>
                 </a:solidFill>
@@ -9787,7 +10372,7 @@
               </a:defRPr>
             </a:pPr>
             <a:r>
-              <a:t>• Shuffling A does NOT drop it → the signal lives in the decoder (D·Dᵀ), not A.</a:t>
+              <a:t>• probe_A ≤ 0.16 (soft gate): A a minor add-on.</a:t>
             </a:r>
           </a:p>
           <a:p>
@@ -9795,7 +10380,7 @@
               <a:spcAft>
                 <a:spcPts val="600"/>
               </a:spcAft>
-              <a:defRPr sz="1350">
+              <a:defRPr sz="1300">
                 <a:solidFill>
                   <a:srgbClr val="1A1A2E"/>
                 </a:solidFill>
@@ -9803,7 +10388,7 @@
               </a:defRPr>
             </a:pPr>
             <a:r>
-              <a:t>• Fetal-atlas FATE hierarchy: AUROC 0.51 = chance → no developmental structure.</a:t>
+              <a:t>• crossTF_div ≈ 0.02: ~99% identical predictions across TFs = mode collapse.</a:t>
             </a:r>
           </a:p>
           <a:p>
@@ -9811,7 +10396,7 @@
               <a:spcAft>
                 <a:spcPts val="600"/>
               </a:spcAft>
-              <a:defRPr sz="1350">
+              <a:defRPr sz="1300">
                 <a:solidFill>
                   <a:srgbClr val="1A1A2E"/>
                 </a:solidFill>
@@ -9819,14 +10404,14 @@
               </a:defRPr>
             </a:pPr>
             <a:r>
-              <a:t>• random-D → chance confirms D carries the (co-expression) signal.</a:t>
-            </a:r>
-          </a:p>
-        </p:txBody>
-      </p:sp>
-      <p:sp>
-        <p:nvSpPr>
-          <p:cNvPr id="6" name="TextBox 5"/>
+              <a:t>• A single scalar shift_scale absorbs 27–47% of the pert-loss gradient.</a:t>
+            </a:r>
+          </a:p>
+        </p:txBody>
+      </p:sp>
+      <p:sp>
+        <p:nvSpPr>
+          <p:cNvPr id="8" name="TextBox 7"/>
           <p:cNvSpPr txBox="1"/>
           <p:nvPr/>
         </p:nvSpPr>
@@ -9855,7 +10440,7 @@
               </a:defRPr>
             </a:pPr>
             <a:r>
-              <a:t>Prior-free GRN validation: neither TF→target edges nor developmental hierarchy are recovered from data.</a:t>
+              <a:t>The shift is load-bearing for MAGNITUDE, not identity; the decoder carries the gene-space pattern.</a:t>
             </a:r>
           </a:p>
         </p:txBody>

</xml_diff>

<commit_message>
slides+figures: prior-off ONLY — fig1 (all prior-off, clean legend, whiten fixed), fig3 (prior-off probe values), fig4 (prior-off bars + prior-ON memorization reference line); slide 4 adds run-name recipe map (base/R/arch grids) under the ablation table; consistent prior-off framing
</commit_message>
<xml_diff>
--- a/slides/exp20_load_bearing.pptx
+++ b/slides/exp20_load_bearing.pptx
@@ -7819,7 +7819,7 @@
               </a:defRPr>
             </a:pPr>
             <a:r>
-              <a:t>4 · What we changed — the ablation catalog</a:t>
+              <a:t>4 · What we changed — ablations &amp; the runs (all PRIOR-OFF)</a:t>
             </a:r>
           </a:p>
         </p:txBody>
@@ -7833,8 +7833,8 @@
           <p:nvPr/>
         </p:nvGraphicFramePr>
         <p:xfrm>
-          <a:off x="365760" y="960120"/>
-          <a:ext cx="11475720" cy="2743200"/>
+          <a:off x="365760" y="914400"/>
+          <a:ext cx="11475720" cy="3017520"/>
         </p:xfrm>
         <a:graphic>
           <a:graphicData uri="http://schemas.openxmlformats.org/drawingml/2006/table">
@@ -7843,8 +7843,8 @@
                 <a:tableStyleId>{5C22544A-7EE6-4342-B048-85BDC9FD1C3A}</a:tableStyleId>
               </a:tblPr>
               <a:tblGrid>
-                <a:gridCol w="2286000"/>
-                <a:gridCol w="6537960"/>
+                <a:gridCol w="2331720"/>
+                <a:gridCol w="6492240"/>
                 <a:gridCol w="2651760"/>
               </a:tblGrid>
               <a:tr h="274320">
@@ -7854,7 +7854,7 @@
                     <a:lstStyle/>
                     <a:p>
                       <a:pPr>
-                        <a:defRPr sz="1300" b="1">
+                        <a:defRPr sz="1200" b="1">
                           <a:solidFill>
                             <a:srgbClr val="FFFFFF"/>
                           </a:solidFill>
@@ -7862,7 +7862,7 @@
                         </a:defRPr>
                       </a:pPr>
                       <a:r>
-                        <a:t>Fix / arm</a:t>
+                        <a:t>Fix (ingredient)</a:t>
                       </a:r>
                     </a:p>
                   </a:txBody>
@@ -7878,7 +7878,7 @@
                     <a:lstStyle/>
                     <a:p>
                       <a:pPr>
-                        <a:defRPr sz="1300" b="1">
+                        <a:defRPr sz="1200" b="1">
                           <a:solidFill>
                             <a:srgbClr val="FFFFFF"/>
                           </a:solidFill>
@@ -7902,7 +7902,7 @@
                     <a:lstStyle/>
                     <a:p>
                       <a:pPr>
-                        <a:defRPr sz="1300" b="1">
+                        <a:defRPr sz="1200" b="1">
                           <a:solidFill>
                             <a:srgbClr val="FFFFFF"/>
                           </a:solidFill>
@@ -7928,7 +7928,7 @@
                     <a:lstStyle/>
                     <a:p>
                       <a:pPr>
-                        <a:defRPr sz="1250" b="0">
+                        <a:defRPr sz="1150" b="0">
                           <a:solidFill>
                             <a:srgbClr val="000000"/>
                           </a:solidFill>
@@ -7952,7 +7952,7 @@
                     <a:lstStyle/>
                     <a:p>
                       <a:pPr>
-                        <a:defRPr sz="1250" b="0">
+                        <a:defRPr sz="1150" b="0">
                           <a:solidFill>
                             <a:srgbClr val="000000"/>
                           </a:solidFill>
@@ -7976,7 +7976,7 @@
                     <a:lstStyle/>
                     <a:p>
                       <a:pPr>
-                        <a:defRPr sz="1250" b="0">
+                        <a:defRPr sz="1150" b="0">
                           <a:solidFill>
                             <a:srgbClr val="000000"/>
                           </a:solidFill>
@@ -8002,7 +8002,7 @@
                     <a:lstStyle/>
                     <a:p>
                       <a:pPr>
-                        <a:defRPr sz="1250" b="0">
+                        <a:defRPr sz="1150" b="0">
                           <a:solidFill>
                             <a:srgbClr val="000000"/>
                           </a:solidFill>
@@ -8026,7 +8026,7 @@
                     <a:lstStyle/>
                     <a:p>
                       <a:pPr>
-                        <a:defRPr sz="1250" b="0">
+                        <a:defRPr sz="1150" b="0">
                           <a:solidFill>
                             <a:srgbClr val="000000"/>
                           </a:solidFill>
@@ -8034,7 +8034,7 @@
                         </a:defRPr>
                       </a:pPr>
                       <a:r>
-                        <a:t>2nd ESM head gates programs; L0 on gate existence (soft→hard)</a:t>
+                        <a:t>2nd ESM head gates programs; L0 on gate existence (soft to hard)</a:t>
                       </a:r>
                     </a:p>
                   </a:txBody>
@@ -8050,7 +8050,7 @@
                     <a:lstStyle/>
                     <a:p>
                       <a:pPr>
-                        <a:defRPr sz="1250" b="0">
+                        <a:defRPr sz="1150" b="0">
                           <a:solidFill>
                             <a:srgbClr val="000000"/>
                           </a:solidFill>
@@ -8076,7 +8076,7 @@
                     <a:lstStyle/>
                     <a:p>
                       <a:pPr>
-                        <a:defRPr sz="1250" b="0">
+                        <a:defRPr sz="1150" b="0">
                           <a:solidFill>
                             <a:srgbClr val="000000"/>
                           </a:solidFill>
@@ -8084,7 +8084,7 @@
                         </a:defRPr>
                       </a:pPr>
                       <a:r>
-                        <a:t>prior OFF</a:t>
+                        <a:t>frozen GO+PCA decoder</a:t>
                       </a:r>
                     </a:p>
                   </a:txBody>
@@ -8100,7 +8100,7 @@
                     <a:lstStyle/>
                     <a:p>
                       <a:pPr>
-                        <a:defRPr sz="1250" b="0">
+                        <a:defRPr sz="1150" b="0">
                           <a:solidFill>
                             <a:srgbClr val="000000"/>
                           </a:solidFill>
@@ -8108,7 +8108,7 @@
                         </a:defRPr>
                       </a:pPr>
                       <a:r>
-                        <a:t>remove CollecTRI margin loss (was memorized into G)</a:t>
+                        <a:t>D fixed to GO:BP membership + PCA cols (requires_grad=False)</a:t>
                       </a:r>
                     </a:p>
                   </a:txBody>
@@ -8124,7 +8124,7 @@
                     <a:lstStyle/>
                     <a:p>
                       <a:pPr>
-                        <a:defRPr sz="1250" b="0">
+                        <a:defRPr sz="1150" b="0">
                           <a:solidFill>
                             <a:srgbClr val="000000"/>
                           </a:solidFill>
@@ -8132,7 +8132,7 @@
                         </a:defRPr>
                       </a:pPr>
                       <a:r>
-                        <a:t>honest GRN</a:t>
+                        <a:t>absorption</a:t>
                       </a:r>
                     </a:p>
                   </a:txBody>
@@ -8150,7 +8150,7 @@
                     <a:lstStyle/>
                     <a:p>
                       <a:pPr>
-                        <a:defRPr sz="1250" b="0">
+                        <a:defRPr sz="1150" b="0">
                           <a:solidFill>
                             <a:srgbClr val="000000"/>
                           </a:solidFill>
@@ -8158,7 +8158,7 @@
                         </a:defRPr>
                       </a:pPr>
                       <a:r>
-                        <a:t>frozen GO+PCA decoder</a:t>
+                        <a:t>whitened pert target</a:t>
                       </a:r>
                     </a:p>
                   </a:txBody>
@@ -8174,7 +8174,7 @@
                     <a:lstStyle/>
                     <a:p>
                       <a:pPr>
-                        <a:defRPr sz="1250" b="0">
+                        <a:defRPr sz="1150" b="0">
                           <a:solidFill>
                             <a:srgbClr val="000000"/>
                           </a:solidFill>
@@ -8182,7 +8182,7 @@
                         </a:defRPr>
                       </a:pPr>
                       <a:r>
-                        <a:t>D fixed to GO:BP membership + PCA cols (requires_grad=False)</a:t>
+                        <a:t>MSE on drift-removed + per-gene z-scored residual</a:t>
                       </a:r>
                     </a:p>
                   </a:txBody>
@@ -8198,7 +8198,7 @@
                     <a:lstStyle/>
                     <a:p>
                       <a:pPr>
-                        <a:defRPr sz="1250" b="0">
+                        <a:defRPr sz="1150" b="0">
                           <a:solidFill>
                             <a:srgbClr val="000000"/>
                           </a:solidFill>
@@ -8206,7 +8206,7 @@
                         </a:defRPr>
                       </a:pPr>
                       <a:r>
-                        <a:t>absorption</a:t>
+                        <a:t>mode collapse</a:t>
                       </a:r>
                     </a:p>
                   </a:txBody>
@@ -8224,7 +8224,7 @@
                     <a:lstStyle/>
                     <a:p>
                       <a:pPr>
-                        <a:defRPr sz="1250" b="0">
+                        <a:defRPr sz="1150" b="0">
                           <a:solidFill>
                             <a:srgbClr val="000000"/>
                           </a:solidFill>
@@ -8232,7 +8232,7 @@
                         </a:defRPr>
                       </a:pPr>
                       <a:r>
-                        <a:t>whitened pert target</a:t>
+                        <a:t>pseudobulk target</a:t>
                       </a:r>
                     </a:p>
                   </a:txBody>
@@ -8248,7 +8248,7 @@
                     <a:lstStyle/>
                     <a:p>
                       <a:pPr>
-                        <a:defRPr sz="1250" b="0">
+                        <a:defRPr sz="1150" b="0">
                           <a:solidFill>
                             <a:srgbClr val="000000"/>
                           </a:solidFill>
@@ -8256,7 +8256,7 @@
                         </a:defRPr>
                       </a:pPr>
                       <a:r>
-                        <a:t>MSE on drift-removed + per-gene z-scored residual</a:t>
+                        <a:t>per-TF population-mean delta instead of noisy per-cell mean</a:t>
                       </a:r>
                     </a:p>
                   </a:txBody>
@@ -8272,7 +8272,7 @@
                     <a:lstStyle/>
                     <a:p>
                       <a:pPr>
-                        <a:defRPr sz="1250" b="0">
+                        <a:defRPr sz="1150" b="0">
                           <a:solidFill>
                             <a:srgbClr val="000000"/>
                           </a:solidFill>
@@ -8280,7 +8280,7 @@
                         </a:defRPr>
                       </a:pPr>
                       <a:r>
-                        <a:t>mode collapse</a:t>
+                        <a:t>SNR / collapse</a:t>
                       </a:r>
                     </a:p>
                   </a:txBody>
@@ -8298,7 +8298,7 @@
                     <a:lstStyle/>
                     <a:p>
                       <a:pPr>
-                        <a:defRPr sz="1250" b="0">
+                        <a:defRPr sz="1150" b="0">
                           <a:solidFill>
                             <a:srgbClr val="000000"/>
                           </a:solidFill>
@@ -8306,7 +8306,7 @@
                         </a:defRPr>
                       </a:pPr>
                       <a:r>
-                        <a:t>staged 3-phase L0</a:t>
+                        <a:t>project-out shared dir</a:t>
                       </a:r>
                     </a:p>
                   </a:txBody>
@@ -8322,7 +8322,7 @@
                     <a:lstStyle/>
                     <a:p>
                       <a:pPr>
-                        <a:defRPr sz="1250" b="0">
+                        <a:defRPr sz="1150" b="0">
                           <a:solidFill>
                             <a:srgbClr val="000000"/>
                           </a:solidFill>
@@ -8330,7 +8330,7 @@
                         </a:defRPr>
                       </a:pPr>
                       <a:r>
-                        <a:t>decouple gate-closing from A-learning (A competent first)</a:t>
+                        <a:t>remove the drift-direction component of the error</a:t>
                       </a:r>
                     </a:p>
                   </a:txBody>
@@ -8346,7 +8346,7 @@
                     <a:lstStyle/>
                     <a:p>
                       <a:pPr>
-                        <a:defRPr sz="1250" b="0">
+                        <a:defRPr sz="1150" b="0">
                           <a:solidFill>
                             <a:srgbClr val="000000"/>
                           </a:solidFill>
@@ -8354,7 +8354,7 @@
                         </a:defRPr>
                       </a:pPr>
                       <a:r>
-                        <a:t>gate-vs-A race</a:t>
+                        <a:t>shared handling</a:t>
                       </a:r>
                     </a:p>
                   </a:txBody>
@@ -8372,7 +8372,7 @@
                     <a:lstStyle/>
                     <a:p>
                       <a:pPr>
-                        <a:defRPr sz="1250" b="0">
+                        <a:defRPr sz="1150" b="0">
                           <a:solidFill>
                             <a:srgbClr val="000000"/>
                           </a:solidFill>
@@ -8380,7 +8380,7 @@
                         </a:defRPr>
                       </a:pPr>
                       <a:r>
-                        <a:t>nonlinear SCM</a:t>
+                        <a:t>staged 3-phase L0</a:t>
                       </a:r>
                     </a:p>
                   </a:txBody>
@@ -8396,7 +8396,7 @@
                     <a:lstStyle/>
                     <a:p>
                       <a:pPr>
-                        <a:defRPr sz="1250" b="0">
+                        <a:defRPr sz="1150" b="0">
                           <a:solidFill>
                             <a:srgbClr val="000000"/>
                           </a:solidFill>
@@ -8404,7 +8404,7 @@
                         </a:defRPr>
                       </a:pPr>
                       <a:r>
-                        <a:t>z=tanh(Aᵀz)+ε via Picard; Jacobian GRN</a:t>
+                        <a:t>decouple gate-closing from A-learning (A competent first)</a:t>
                       </a:r>
                     </a:p>
                   </a:txBody>
@@ -8420,7 +8420,7 @@
                     <a:lstStyle/>
                     <a:p>
                       <a:pPr>
-                        <a:defRPr sz="1250" b="0">
+                        <a:defRPr sz="1150" b="0">
                           <a:solidFill>
                             <a:srgbClr val="000000"/>
                           </a:solidFill>
@@ -8428,7 +8428,7 @@
                         </a:defRPr>
                       </a:pPr>
                       <a:r>
-                        <a:t>A expressiveness</a:t>
+                        <a:t>gate-vs-A race</a:t>
                       </a:r>
                     </a:p>
                   </a:txBody>
@@ -8446,7 +8446,7 @@
                     <a:lstStyle/>
                     <a:p>
                       <a:pPr>
-                        <a:defRPr sz="1250" b="0">
+                        <a:defRPr sz="1150" b="0">
                           <a:solidFill>
                             <a:srgbClr val="000000"/>
                           </a:solidFill>
@@ -8454,7 +8454,7 @@
                         </a:defRPr>
                       </a:pPr>
                       <a:r>
-                        <a:t>hard self-gate</a:t>
+                        <a:t>nonlinear SCM</a:t>
                       </a:r>
                     </a:p>
                   </a:txBody>
@@ -8470,7 +8470,7 @@
                     <a:lstStyle/>
                     <a:p>
                       <a:pPr>
-                        <a:defRPr sz="1250" b="0">
+                        <a:defRPr sz="1150" b="0">
                           <a:solidFill>
                             <a:srgbClr val="000000"/>
                           </a:solidFill>
@@ -8478,7 +8478,7 @@
                         </a:defRPr>
                       </a:pPr>
                       <a:r>
-                        <a:t>shift restricted to gene g’s own top-k decoder programs</a:t>
+                        <a:t>z=tanh(A^T z)+eps via Picard; Jacobian GRN</a:t>
                       </a:r>
                     </a:p>
                   </a:txBody>
@@ -8494,7 +8494,7 @@
                     <a:lstStyle/>
                     <a:p>
                       <a:pPr>
-                        <a:defRPr sz="1250" b="0">
+                        <a:defRPr sz="1150" b="0">
                           <a:solidFill>
                             <a:srgbClr val="000000"/>
                           </a:solidFill>
@@ -8502,7 +8502,7 @@
                         </a:defRPr>
                       </a:pPr>
                       <a:r>
-                        <a:t>localization</a:t>
+                        <a:t>A expressiveness</a:t>
                       </a:r>
                     </a:p>
                   </a:txBody>
@@ -8520,7 +8520,7 @@
                     <a:lstStyle/>
                     <a:p>
                       <a:pPr>
-                        <a:defRPr sz="1250" b="0">
+                        <a:defRPr sz="1150" b="0">
                           <a:solidFill>
                             <a:srgbClr val="000000"/>
                           </a:solidFill>
@@ -8528,7 +8528,7 @@
                         </a:defRPr>
                       </a:pPr>
                       <a:r>
-                        <a:t>multi-context (+Norman)</a:t>
+                        <a:t>hard self-gate</a:t>
                       </a:r>
                     </a:p>
                   </a:txBody>
@@ -8544,7 +8544,7 @@
                     <a:lstStyle/>
                     <a:p>
                       <a:pPr>
-                        <a:defRPr sz="1250" b="0">
+                        <a:defRPr sz="1150" b="0">
                           <a:solidFill>
                             <a:srgbClr val="000000"/>
                           </a:solidFill>
@@ -8552,7 +8552,7 @@
                         </a:defRPr>
                       </a:pPr>
                       <a:r>
-                        <a:t>2nd cell context via modality token; ESM bridge; shared held-out</a:t>
+                        <a:t>shift restricted to gene g own top-k decoder programs</a:t>
                       </a:r>
                     </a:p>
                   </a:txBody>
@@ -8568,7 +8568,81 @@
                     <a:lstStyle/>
                     <a:p>
                       <a:pPr>
-                        <a:defRPr sz="1250" b="0">
+                        <a:defRPr sz="1150" b="0">
+                          <a:solidFill>
+                            <a:srgbClr val="000000"/>
+                          </a:solidFill>
+                          <a:latin typeface="Calibri"/>
+                        </a:defRPr>
+                      </a:pPr>
+                      <a:r>
+                        <a:t>localization</a:t>
+                      </a:r>
+                    </a:p>
+                  </a:txBody>
+                  <a:tcPr marT="12700" marB="12700">
+                    <a:solidFill>
+                      <a:srgbClr val="F5F5F5"/>
+                    </a:solidFill>
+                  </a:tcPr>
+                </a:tc>
+              </a:tr>
+              <a:tr h="274320">
+                <a:tc>
+                  <a:txBody>
+                    <a:bodyPr/>
+                    <a:lstStyle/>
+                    <a:p>
+                      <a:pPr>
+                        <a:defRPr sz="1150" b="0">
+                          <a:solidFill>
+                            <a:srgbClr val="000000"/>
+                          </a:solidFill>
+                          <a:latin typeface="Calibri"/>
+                        </a:defRPr>
+                      </a:pPr>
+                      <a:r>
+                        <a:t>multi-context (+Norman)</a:t>
+                      </a:r>
+                    </a:p>
+                  </a:txBody>
+                  <a:tcPr marT="12700" marB="12700">
+                    <a:solidFill>
+                      <a:srgbClr val="FFFFFF"/>
+                    </a:solidFill>
+                  </a:tcPr>
+                </a:tc>
+                <a:tc>
+                  <a:txBody>
+                    <a:bodyPr/>
+                    <a:lstStyle/>
+                    <a:p>
+                      <a:pPr>
+                        <a:defRPr sz="1150" b="0">
+                          <a:solidFill>
+                            <a:srgbClr val="000000"/>
+                          </a:solidFill>
+                          <a:latin typeface="Calibri"/>
+                        </a:defRPr>
+                      </a:pPr>
+                      <a:r>
+                        <a:t>2nd cell context via modality token; ESM bridge; shared held-out</a:t>
+                      </a:r>
+                    </a:p>
+                  </a:txBody>
+                  <a:tcPr marT="12700" marB="12700">
+                    <a:solidFill>
+                      <a:srgbClr val="FFFFFF"/>
+                    </a:solidFill>
+                  </a:tcPr>
+                </a:tc>
+                <a:tc>
+                  <a:txBody>
+                    <a:bodyPr/>
+                    <a:lstStyle/>
+                    <a:p>
+                      <a:pPr>
+                        <a:defRPr sz="1150" b="0">
                           <a:solidFill>
                             <a:srgbClr val="000000"/>
                           </a:solidFill>
@@ -8582,7 +8656,7 @@
                   </a:txBody>
                   <a:tcPr marT="12700" marB="12700">
                     <a:solidFill>
-                      <a:srgbClr val="F5F5F5"/>
+                      <a:srgbClr val="FFFFFF"/>
                     </a:solidFill>
                   </a:tcPr>
                 </a:tc>
@@ -8591,30 +8665,52 @@
           </a:graphicData>
         </a:graphic>
       </p:graphicFrame>
-      <p:pic>
-        <p:nvPicPr>
-          <p:cNvPr id="5" name="Picture 4" descr="l0.png"/>
-          <p:cNvPicPr>
-            <a:picLocks noChangeAspect="1"/>
-          </p:cNvPicPr>
-          <p:nvPr/>
-        </p:nvPicPr>
-        <p:blipFill>
-          <a:blip r:embed="rId2"/>
-          <a:stretch>
-            <a:fillRect/>
-          </a:stretch>
-        </p:blipFill>
-        <p:spPr>
-          <a:xfrm>
-            <a:off x="457200" y="4937760"/>
-            <a:ext cx="2651760" cy="1215248"/>
-          </a:xfrm>
-          <a:prstGeom prst="rect">
-            <a:avLst/>
-          </a:prstGeom>
-        </p:spPr>
-      </p:pic>
+      <p:sp>
+        <p:nvSpPr>
+          <p:cNvPr id="5" name="Rounded Rectangle 4"/>
+          <p:cNvSpPr/>
+          <p:nvPr/>
+        </p:nvSpPr>
+        <p:spPr>
+          <a:xfrm>
+            <a:off x="365760" y="4389120"/>
+            <a:ext cx="11475720" cy="1874519"/>
+          </a:xfrm>
+          <a:prstGeom prst="roundRect">
+            <a:avLst/>
+          </a:prstGeom>
+          <a:solidFill>
+            <a:srgbClr val="F3F6FC"/>
+          </a:solidFill>
+          <a:ln w="19050">
+            <a:solidFill>
+              <a:srgbClr val="2171B5"/>
+            </a:solidFill>
+          </a:ln>
+          <a:effectLst/>
+        </p:spPr>
+        <p:style>
+          <a:lnRef idx="1">
+            <a:schemeClr val="accent1"/>
+          </a:lnRef>
+          <a:fillRef idx="3">
+            <a:schemeClr val="accent1"/>
+          </a:fillRef>
+          <a:effectRef idx="2">
+            <a:schemeClr val="accent1"/>
+          </a:effectRef>
+          <a:fontRef idx="minor">
+            <a:schemeClr val="lt1"/>
+          </a:fontRef>
+        </p:style>
+        <p:txBody>
+          <a:bodyPr rtlCol="0" anchor="ctr"/>
+          <a:lstStyle/>
+          <a:p>
+            <a:pPr algn="ctr"/>
+          </a:p>
+        </p:txBody>
+      </p:sp>
       <p:sp>
         <p:nvSpPr>
           <p:cNvPr id="6" name="TextBox 5"/>
@@ -8623,8 +8719,8 @@
         </p:nvSpPr>
         <p:spPr>
           <a:xfrm>
-            <a:off x="3200400" y="5074920"/>
-            <a:ext cx="6400800" cy="320040"/>
+            <a:off x="548640" y="4462272"/>
+            <a:ext cx="10972800" cy="365760"/>
           </a:xfrm>
           <a:prstGeom prst="rect">
             <a:avLst/>
@@ -8637,16 +8733,16 @@
           </a:bodyPr>
           <a:lstStyle/>
           <a:p>
-            <a:pPr algn="l">
-              <a:defRPr sz="1200" b="0" i="1">
-                <a:solidFill>
-                  <a:srgbClr val="666666"/>
+            <a:pPr>
+              <a:defRPr sz="1500" b="1">
+                <a:solidFill>
+                  <a:srgbClr val="0B3D91"/>
                 </a:solidFill>
                 <a:latin typeface="Calibri"/>
               </a:defRPr>
             </a:pPr>
             <a:r>
-              <a:t>— penalize gate EXISTENCE (L0), not magnitude (L1)</a:t>
+              <a:t>The runs  (recipe -&gt; name)</a:t>
             </a:r>
           </a:p>
         </p:txBody>
@@ -8659,8 +8755,8 @@
         </p:nvSpPr>
         <p:spPr>
           <a:xfrm>
-            <a:off x="365760" y="6455664"/>
-            <a:ext cx="11430000" cy="320040"/>
+            <a:off x="548640" y="4846320"/>
+            <a:ext cx="11247120" cy="1371600"/>
           </a:xfrm>
           <a:prstGeom prst="rect">
             <a:avLst/>
@@ -8673,6 +8769,77 @@
           </a:bodyPr>
           <a:lstStyle/>
           <a:p>
+            <a:pPr>
+              <a:spcAft>
+                <a:spcPts val="500"/>
+              </a:spcAft>
+              <a:defRPr sz="1150">
+                <a:solidFill>
+                  <a:srgbClr val="000000"/>
+                </a:solidFill>
+                <a:latin typeface="Calibri"/>
+              </a:defRPr>
+            </a:pPr>
+            <a:r>
+              <a:t>• Base arms (grid x20po):  min_esm = Fix1 only  .  sparse_esm = +Fix2 gate  .  sparse_con = +InfoNCE contrastive  .  sparse_resid = +drift-removed target  .  sparse_pertonly = +down-weighted recon  .  sparse_residrecon = +residual recon  .  sparse_all = all</a:t>
+            </a:r>
+          </a:p>
+          <a:p>
+            <a:pPr>
+              <a:spcAft>
+                <a:spcPts val="500"/>
+              </a:spcAft>
+              <a:defRPr sz="1150">
+                <a:solidFill>
+                  <a:srgbClr val="000000"/>
+                </a:solidFill>
+                <a:latin typeface="Calibri"/>
+              </a:defRPr>
+            </a:pPr>
+            <a:r>
+              <a:t>• Objective sweep (grid x20R, on sparse_con base):  R1 per-example  .  R2 pseudobulk  .  R3 project-out  .  R4 pseudobulk+project  .  R5 = R4 + contrastive x10  .  R6 = R4 + energy/MMD</a:t>
+            </a:r>
+          </a:p>
+          <a:p>
+            <a:pPr>
+              <a:spcAft>
+                <a:spcPts val="500"/>
+              </a:spcAft>
+              <a:defRPr sz="1150">
+                <a:solidFill>
+                  <a:srgbClr val="000000"/>
+                </a:solidFill>
+                <a:latin typeface="Calibri"/>
+              </a:defRPr>
+            </a:pPr>
+            <a:r>
+              <a:t>• Architecture (x20arch / x20frz):  staged_esm, staged_con (staged L0)  .  whiten  .  nonlinSCM  .  frozenD64 (+nonlin / +whiten)   .   In flight: J1/J2 (hard self-gate), JN0/JN1 (Joung+Norman)</a:t>
+            </a:r>
+          </a:p>
+        </p:txBody>
+      </p:sp>
+      <p:sp>
+        <p:nvSpPr>
+          <p:cNvPr id="8" name="TextBox 7"/>
+          <p:cNvSpPr txBox="1"/>
+          <p:nvPr/>
+        </p:nvSpPr>
+        <p:spPr>
+          <a:xfrm>
+            <a:off x="365760" y="6455664"/>
+            <a:ext cx="11430000" cy="320040"/>
+          </a:xfrm>
+          <a:prstGeom prst="rect">
+            <a:avLst/>
+          </a:prstGeom>
+          <a:noFill/>
+        </p:spPr>
+        <p:txBody>
+          <a:bodyPr wrap="square">
+            <a:spAutoFit/>
+          </a:bodyPr>
+          <a:lstStyle/>
+          <a:p>
             <a:pPr algn="l">
               <a:defRPr sz="1000" b="0" i="1">
                 <a:solidFill>
@@ -8682,7 +8849,7 @@
               </a:defRPr>
             </a:pPr>
             <a:r>
-              <a:t>~30 arms across grids x20 (prior-on), x20po (prior-off), x20arch, x20R (objective), x20frz (frozen), + synthetic.</a:t>
+              <a:t>Grids: x20po (prior-off base) . x20R (objective) . x20arch/x20frz (architecture) . synthetic (identifiability). Prior-ON x20 kept only as the GRN memorization control.</a:t>
             </a:r>
           </a:p>
         </p:txBody>

</xml_diff>